<commit_message>
Add DOCX and update PPTX files
Adds a new .docx file and updates an existing .pptx (both have Cyrillic filenames). The changeset introduces the new binary document and replaces the binary presentation file; no source code or textual changes.
</commit_message>
<xml_diff>
--- a/Презентация ДП Подъячев.pptx
+++ b/Презентация ДП Подъячев.pptx
@@ -34524,15 +34524,15 @@
           <a:lstStyle/>
           <a:p>
             <a:r>
-              <a:rPr lang="ru-RU" sz="4000" dirty="0"/>
+              <a:rPr lang="ru-RU" sz="3800" dirty="0"/>
               <a:t>«</a:t>
             </a:r>
             <a:r>
-              <a:rPr lang="ru-RU" sz="4000" i="1" dirty="0"/>
+              <a:rPr lang="ru-RU" sz="3800" i="1" dirty="0"/>
               <a:t>Разработка программного комплекса для оптимизации маршрутов доставки на основе алгоритма "Ближайшего соседа" и его сравнительный анализ с другими жадными алгоритмами</a:t>
             </a:r>
             <a:r>
-              <a:rPr lang="ru-RU" sz="4000" dirty="0"/>
+              <a:rPr lang="ru-RU" sz="3800" dirty="0"/>
               <a:t>»</a:t>
             </a:r>
           </a:p>
@@ -34811,8 +34811,8 @@
         </p:nvSpPr>
         <p:spPr>
           <a:xfrm>
-            <a:off x="901700" y="3746500"/>
-            <a:ext cx="4902200" cy="4524315"/>
+            <a:off x="901700" y="2761614"/>
+            <a:ext cx="5346700" cy="5940088"/>
           </a:xfrm>
           <a:prstGeom prst="rect">
             <a:avLst/>
@@ -34826,16 +34826,16 @@
           <a:lstStyle/>
           <a:p>
             <a:r>
-              <a:rPr lang="ru-RU" sz="3200" dirty="0"/>
+              <a:rPr lang="ru-RU" sz="3800" dirty="0"/>
               <a:t>Цель</a:t>
             </a:r>
           </a:p>
           <a:p>
-            <a:endParaRPr lang="ru-RU" sz="3200" dirty="0"/>
+            <a:endParaRPr lang="ru-RU" sz="3800" dirty="0"/>
           </a:p>
           <a:p>
             <a:r>
-              <a:rPr lang="ru-RU" sz="3200" dirty="0"/>
+              <a:rPr lang="ru-RU" sz="3800" dirty="0"/>
               <a:t>Создание программного инструмента для автоматизации маршрутизации и оценки эффективности алгоритмов.</a:t>
             </a:r>
           </a:p>
@@ -34855,8 +34855,8 @@
         </p:nvSpPr>
         <p:spPr>
           <a:xfrm>
-            <a:off x="6692900" y="3746500"/>
-            <a:ext cx="4902200" cy="3539430"/>
+            <a:off x="6534149" y="2758221"/>
+            <a:ext cx="5219700" cy="4770537"/>
           </a:xfrm>
           <a:prstGeom prst="rect">
             <a:avLst/>
@@ -34870,39 +34870,39 @@
           <a:lstStyle/>
           <a:p>
             <a:r>
-              <a:rPr lang="ru-RU" sz="3200" dirty="0"/>
+              <a:rPr lang="ru-RU" sz="3800" dirty="0"/>
               <a:t>Разработка</a:t>
             </a:r>
           </a:p>
           <a:p>
-            <a:endParaRPr lang="ru-RU" sz="3200" dirty="0"/>
+            <a:endParaRPr lang="ru-RU" sz="3800" dirty="0"/>
           </a:p>
           <a:p>
             <a:r>
-              <a:rPr lang="ru-RU" sz="3200" dirty="0"/>
+              <a:rPr lang="ru-RU" sz="3800" dirty="0"/>
               <a:t>Реализация аналитического модуля на </a:t>
             </a:r>
             <a:r>
-              <a:rPr lang="en-US" sz="3200" dirty="0"/>
+              <a:rPr lang="en-US" sz="3800" dirty="0"/>
               <a:t>Python </a:t>
             </a:r>
             <a:r>
-              <a:rPr lang="ru-RU" sz="3200" dirty="0"/>
+              <a:rPr lang="ru-RU" sz="3800" dirty="0"/>
               <a:t>и веб-интерфейса «Навигатор </a:t>
             </a:r>
             <a:r>
-              <a:rPr lang="en-US" sz="3200" dirty="0"/>
+              <a:rPr lang="en-US" sz="3800" dirty="0"/>
               <a:t>AI</a:t>
             </a:r>
             <a:r>
-              <a:rPr lang="ru-RU" sz="3200" dirty="0"/>
+              <a:rPr lang="ru-RU" sz="3800" dirty="0"/>
               <a:t>» на </a:t>
             </a:r>
             <a:r>
-              <a:rPr lang="en-US" sz="3200" dirty="0"/>
+              <a:rPr lang="en-US" sz="3800" dirty="0"/>
               <a:t>JavaScript</a:t>
             </a:r>
-            <a:endParaRPr lang="ru-RU" sz="3200" dirty="0"/>
+            <a:endParaRPr lang="ru-RU" sz="3800" dirty="0"/>
           </a:p>
         </p:txBody>
       </p:sp>
@@ -34920,8 +34920,8 @@
         </p:nvSpPr>
         <p:spPr>
           <a:xfrm>
-            <a:off x="12484100" y="3746499"/>
-            <a:ext cx="4902200" cy="3539430"/>
+            <a:off x="12458700" y="2758231"/>
+            <a:ext cx="5219700" cy="4770537"/>
           </a:xfrm>
           <a:prstGeom prst="rect">
             <a:avLst/>
@@ -34935,34 +34935,124 @@
           <a:lstStyle/>
           <a:p>
             <a:r>
-              <a:rPr lang="ru-RU" sz="3200" dirty="0"/>
+              <a:rPr lang="ru-RU" sz="3800" dirty="0"/>
               <a:t>Анализ</a:t>
             </a:r>
           </a:p>
           <a:p>
-            <a:endParaRPr lang="ru-RU" sz="3200" dirty="0"/>
+            <a:endParaRPr lang="ru-RU" sz="3800" dirty="0"/>
           </a:p>
           <a:p>
             <a:r>
-              <a:rPr lang="ru-RU" sz="3200" dirty="0"/>
+              <a:rPr lang="ru-RU" sz="3800" dirty="0"/>
               <a:t>Сравнительный анализ алгоритма </a:t>
             </a:r>
             <a:r>
-              <a:rPr lang="en-US" sz="3200" dirty="0"/>
+              <a:rPr lang="en-US" sz="3800" dirty="0"/>
               <a:t>NN </a:t>
             </a:r>
             <a:r>
-              <a:rPr lang="ru-RU" sz="3200" dirty="0"/>
+              <a:rPr lang="ru-RU" sz="3800" dirty="0"/>
               <a:t>с альтернативными жадными методами и постобработкой </a:t>
             </a:r>
             <a:r>
-              <a:rPr lang="en-US" sz="3200" dirty="0"/>
+              <a:rPr lang="en-US" sz="3800" dirty="0"/>
               <a:t>2-opt</a:t>
             </a:r>
-            <a:endParaRPr lang="ru-RU" sz="3200" dirty="0"/>
+            <a:endParaRPr lang="ru-RU" sz="3800" dirty="0"/>
           </a:p>
         </p:txBody>
       </p:sp>
+      <p:pic>
+        <p:nvPicPr>
+          <p:cNvPr id="6" name="Рисунок 5">
+            <a:extLst>
+              <a:ext uri="{FF2B5EF4-FFF2-40B4-BE49-F238E27FC236}">
+                <a16:creationId xmlns:a16="http://schemas.microsoft.com/office/drawing/2014/main" id="{B7C6D251-8ABA-606D-A6A1-D1CB9FF8A52F}"/>
+              </a:ext>
+            </a:extLst>
+          </p:cNvPr>
+          <p:cNvPicPr>
+            <a:picLocks noChangeAspect="1"/>
+          </p:cNvPicPr>
+          <p:nvPr/>
+        </p:nvPicPr>
+        <p:blipFill>
+          <a:blip r:embed="rId3"/>
+          <a:stretch>
+            <a:fillRect/>
+          </a:stretch>
+        </p:blipFill>
+        <p:spPr>
+          <a:xfrm>
+            <a:off x="1028700" y="1735176"/>
+            <a:ext cx="749300" cy="749300"/>
+          </a:xfrm>
+          <a:prstGeom prst="rect">
+            <a:avLst/>
+          </a:prstGeom>
+        </p:spPr>
+      </p:pic>
+      <p:pic>
+        <p:nvPicPr>
+          <p:cNvPr id="9" name="Рисунок 8">
+            <a:extLst>
+              <a:ext uri="{FF2B5EF4-FFF2-40B4-BE49-F238E27FC236}">
+                <a16:creationId xmlns:a16="http://schemas.microsoft.com/office/drawing/2014/main" id="{BC48E023-B11A-C442-8D78-6A019BEF81EB}"/>
+              </a:ext>
+            </a:extLst>
+          </p:cNvPr>
+          <p:cNvPicPr>
+            <a:picLocks noChangeAspect="1"/>
+          </p:cNvPicPr>
+          <p:nvPr/>
+        </p:nvPicPr>
+        <p:blipFill>
+          <a:blip r:embed="rId4"/>
+          <a:stretch>
+            <a:fillRect/>
+          </a:stretch>
+        </p:blipFill>
+        <p:spPr>
+          <a:xfrm>
+            <a:off x="6692900" y="1531967"/>
+            <a:ext cx="952509" cy="952509"/>
+          </a:xfrm>
+          <a:prstGeom prst="rect">
+            <a:avLst/>
+          </a:prstGeom>
+        </p:spPr>
+      </p:pic>
+      <p:pic>
+        <p:nvPicPr>
+          <p:cNvPr id="11" name="Рисунок 10">
+            <a:extLst>
+              <a:ext uri="{FF2B5EF4-FFF2-40B4-BE49-F238E27FC236}">
+                <a16:creationId xmlns:a16="http://schemas.microsoft.com/office/drawing/2014/main" id="{57E2B113-E062-C455-13B1-8CE6A6E75157}"/>
+              </a:ext>
+            </a:extLst>
+          </p:cNvPr>
+          <p:cNvPicPr>
+            <a:picLocks noChangeAspect="1"/>
+          </p:cNvPicPr>
+          <p:nvPr/>
+        </p:nvPicPr>
+        <p:blipFill>
+          <a:blip r:embed="rId5"/>
+          <a:stretch>
+            <a:fillRect/>
+          </a:stretch>
+        </p:blipFill>
+        <p:spPr>
+          <a:xfrm>
+            <a:off x="12458700" y="1414112"/>
+            <a:ext cx="1070364" cy="1070364"/>
+          </a:xfrm>
+          <a:prstGeom prst="rect">
+            <a:avLst/>
+          </a:prstGeom>
+        </p:spPr>
+      </p:pic>
     </p:spTree>
   </p:cSld>
   <p:clrMapOvr>
@@ -35016,24 +35106,38 @@
           </a:p>
         </p:txBody>
       </p:sp>
-      <p:sp>
-        <p:nvSpPr>
-          <p:cNvPr id="3" name="Рисунок 2">
-            <a:extLst>
-              <a:ext uri="{FF2B5EF4-FFF2-40B4-BE49-F238E27FC236}">
-                <a16:creationId xmlns:a16="http://schemas.microsoft.com/office/drawing/2014/main" id="{F1504C27-FD0D-459C-B6C6-F83F53CD6257}"/>
-              </a:ext>
-            </a:extLst>
-          </p:cNvPr>
-          <p:cNvSpPr>
-            <a:spLocks noGrp="1"/>
-          </p:cNvSpPr>
+      <p:pic>
+        <p:nvPicPr>
+          <p:cNvPr id="8" name="Рисунок 7">
+            <a:extLst>
+              <a:ext uri="{FF2B5EF4-FFF2-40B4-BE49-F238E27FC236}">
+                <a16:creationId xmlns:a16="http://schemas.microsoft.com/office/drawing/2014/main" id="{2F03A702-44FA-4B51-8D08-B64532F2BB78}"/>
+              </a:ext>
+            </a:extLst>
+          </p:cNvPr>
+          <p:cNvPicPr>
+            <a:picLocks noGrp="1" noChangeAspect="1"/>
+          </p:cNvPicPr>
           <p:nvPr>
             <p:ph type="pic" sz="quarter" idx="11"/>
           </p:nvPr>
-        </p:nvSpPr>
-        <p:spPr/>
-      </p:sp>
+        </p:nvPicPr>
+        <p:blipFill>
+          <a:blip r:embed="rId3"/>
+          <a:srcRect t="1158" b="1158"/>
+          <a:stretch/>
+        </p:blipFill>
+        <p:spPr>
+          <a:prstGeom prst="roundRect">
+            <a:avLst>
+              <a:gd name="adj" fmla="val 5708"/>
+            </a:avLst>
+          </a:prstGeom>
+          <a:effectLst>
+            <a:softEdge rad="38100"/>
+          </a:effectLst>
+        </p:spPr>
+      </p:pic>
       <p:sp>
         <p:nvSpPr>
           <p:cNvPr id="4" name="Текст 3">
@@ -35062,7 +35166,11 @@
           <a:p>
             <a:pPr algn="just"/>
             <a:r>
-              <a:rPr lang="ru-RU" b="1" dirty="0" err="1"/>
+              <a:rPr lang="ru-RU" dirty="0"/>
+              <a:t>1) </a:t>
+            </a:r>
+            <a:r>
+              <a:rPr lang="ru-RU" dirty="0" err="1"/>
               <a:t>Nearest</a:t>
             </a:r>
             <a:r>
@@ -35075,11 +35183,11 @@
             </a:r>
             <a:r>
               <a:rPr lang="ru-RU" b="1" dirty="0"/>
-              <a:t> (NN):</a:t>
+              <a:t> (NN): </a:t>
             </a:r>
             <a:r>
               <a:rPr lang="ru-RU" dirty="0"/>
-              <a:t> поиск ближайшей </a:t>
+              <a:t>поиск ближайшей </a:t>
             </a:r>
             <a:r>
               <a:rPr lang="ru-RU" dirty="0" err="1"/>
@@ -35093,20 +35201,16 @@
           <a:p>
             <a:pPr algn="just"/>
             <a:r>
-              <a:rPr lang="ru-RU" b="1" dirty="0"/>
-              <a:t>2-opt </a:t>
-            </a:r>
-            <a:r>
-              <a:rPr lang="ru-RU" b="1" dirty="0" err="1"/>
+              <a:rPr lang="ru-RU" dirty="0"/>
+              <a:t>2) 2-opt </a:t>
+            </a:r>
+            <a:r>
+              <a:rPr lang="ru-RU" dirty="0" err="1"/>
               <a:t>Heuristic</a:t>
             </a:r>
             <a:r>
-              <a:rPr lang="ru-RU" b="1" dirty="0"/>
-              <a:t>:</a:t>
-            </a:r>
-            <a:r>
               <a:rPr lang="ru-RU" dirty="0"/>
-              <a:t> устранение самопересечений маршрута путем переворота </a:t>
+              <a:t>: устранение самопересечений маршрута путем переворота </a:t>
             </a:r>
             <a:r>
               <a:rPr lang="ru-RU" dirty="0" err="1"/>
@@ -35121,7 +35225,7 @@
             <a:pPr algn="just"/>
             <a:r>
               <a:rPr lang="ru-RU" b="1" dirty="0"/>
-              <a:t>Гарантии качества:</a:t>
+              <a:t>3) Гарантии качества:</a:t>
             </a:r>
             <a:r>
               <a:rPr lang="ru-RU" dirty="0"/>
@@ -35273,12 +35377,58 @@
           </a:fontRef>
         </p:style>
       </p:cxnSp>
+      <p:sp>
+        <p:nvSpPr>
+          <p:cNvPr id="12" name="Прямоугольник 11">
+            <a:extLst>
+              <a:ext uri="{FF2B5EF4-FFF2-40B4-BE49-F238E27FC236}">
+                <a16:creationId xmlns:a16="http://schemas.microsoft.com/office/drawing/2014/main" id="{24EE318C-09DA-5A4C-A09F-47C90612D497}"/>
+              </a:ext>
+            </a:extLst>
+          </p:cNvPr>
+          <p:cNvSpPr/>
+          <p:nvPr/>
+        </p:nvSpPr>
+        <p:spPr>
+          <a:xfrm>
+            <a:off x="17708148" y="9631429"/>
+            <a:ext cx="431528" cy="584775"/>
+          </a:xfrm>
+          <a:prstGeom prst="rect">
+            <a:avLst/>
+          </a:prstGeom>
+          <a:noFill/>
+        </p:spPr>
+        <p:txBody>
+          <a:bodyPr wrap="none" lIns="91440" tIns="45720" rIns="91440" bIns="45720">
+            <a:spAutoFit/>
+          </a:bodyPr>
+          <a:lstStyle/>
+          <a:p>
+            <a:pPr algn="ctr"/>
+            <a:r>
+              <a:rPr lang="ru-RU" sz="3200" b="0" cap="none" spc="0" dirty="0">
+                <a:ln w="0"/>
+                <a:effectLst>
+                  <a:outerShdw blurRad="38100" dist="25400" dir="5400000" algn="ctr" rotWithShape="0">
+                    <a:srgbClr val="6E747A">
+                      <a:alpha val="43000"/>
+                    </a:srgbClr>
+                  </a:outerShdw>
+                </a:effectLst>
+                <a:latin typeface="Nunito Bold" pitchFamily="2" charset="-52"/>
+              </a:rPr>
+              <a:t>4</a:t>
+            </a:r>
+          </a:p>
+        </p:txBody>
+      </p:sp>
       <p:pic>
         <p:nvPicPr>
-          <p:cNvPr id="11" name="Рисунок 10">
-            <a:extLst>
-              <a:ext uri="{FF2B5EF4-FFF2-40B4-BE49-F238E27FC236}">
-                <a16:creationId xmlns:a16="http://schemas.microsoft.com/office/drawing/2014/main" id="{D433F965-5B11-6B3B-182D-C085749BDB3A}"/>
+          <p:cNvPr id="4" name="Рисунок 3">
+            <a:extLst>
+              <a:ext uri="{FF2B5EF4-FFF2-40B4-BE49-F238E27FC236}">
+                <a16:creationId xmlns:a16="http://schemas.microsoft.com/office/drawing/2014/main" id="{71BB7EFD-1782-9186-18D4-1AB39BA62D21}"/>
               </a:ext>
             </a:extLst>
           </p:cNvPr>
@@ -35295,60 +35445,14 @@
         </p:blipFill>
         <p:spPr>
           <a:xfrm>
-            <a:off x="2329556" y="1786018"/>
-            <a:ext cx="13628888" cy="6714963"/>
+            <a:off x="1782407" y="1366044"/>
+            <a:ext cx="14514826" cy="7554912"/>
           </a:xfrm>
           <a:prstGeom prst="rect">
             <a:avLst/>
           </a:prstGeom>
         </p:spPr>
       </p:pic>
-      <p:sp>
-        <p:nvSpPr>
-          <p:cNvPr id="12" name="Прямоугольник 11">
-            <a:extLst>
-              <a:ext uri="{FF2B5EF4-FFF2-40B4-BE49-F238E27FC236}">
-                <a16:creationId xmlns:a16="http://schemas.microsoft.com/office/drawing/2014/main" id="{24EE318C-09DA-5A4C-A09F-47C90612D497}"/>
-              </a:ext>
-            </a:extLst>
-          </p:cNvPr>
-          <p:cNvSpPr/>
-          <p:nvPr/>
-        </p:nvSpPr>
-        <p:spPr>
-          <a:xfrm>
-            <a:off x="17708148" y="9631429"/>
-            <a:ext cx="431528" cy="584775"/>
-          </a:xfrm>
-          <a:prstGeom prst="rect">
-            <a:avLst/>
-          </a:prstGeom>
-          <a:noFill/>
-        </p:spPr>
-        <p:txBody>
-          <a:bodyPr wrap="none" lIns="91440" tIns="45720" rIns="91440" bIns="45720">
-            <a:spAutoFit/>
-          </a:bodyPr>
-          <a:lstStyle/>
-          <a:p>
-            <a:pPr algn="ctr"/>
-            <a:r>
-              <a:rPr lang="ru-RU" sz="3200" b="0" cap="none" spc="0" dirty="0">
-                <a:ln w="0"/>
-                <a:effectLst>
-                  <a:outerShdw blurRad="38100" dist="25400" dir="5400000" algn="ctr" rotWithShape="0">
-                    <a:srgbClr val="6E747A">
-                      <a:alpha val="43000"/>
-                    </a:srgbClr>
-                  </a:outerShdw>
-                </a:effectLst>
-                <a:latin typeface="Nunito Bold" pitchFamily="2" charset="-52"/>
-              </a:rPr>
-              <a:t>4</a:t>
-            </a:r>
-          </a:p>
-        </p:txBody>
-      </p:sp>
     </p:spTree>
   </p:cSld>
   <p:clrMapOvr>
@@ -35402,6 +35506,7 @@
           </a:bodyPr>
           <a:lstStyle/>
           <a:p>
+            <a:pPr algn="ctr"/>
             <a:r>
               <a:rPr lang="ru-RU" sz="6600" dirty="0">
                 <a:solidFill>
@@ -35409,7 +35514,7 @@
                 </a:solidFill>
                 <a:latin typeface="Nunito Bold" pitchFamily="2" charset="-52"/>
               </a:rPr>
-              <a:t>Заключение</a:t>
+              <a:t>Итоги</a:t>
             </a:r>
           </a:p>
         </p:txBody>
@@ -35474,8 +35579,8 @@
         </p:nvSpPr>
         <p:spPr>
           <a:xfrm>
-            <a:off x="2355978" y="2555330"/>
-            <a:ext cx="13576041" cy="4401205"/>
+            <a:off x="2355978" y="1856830"/>
+            <a:ext cx="13576041" cy="6186309"/>
           </a:xfrm>
           <a:prstGeom prst="rect">
             <a:avLst/>
@@ -35490,185 +35595,103 @@
           <a:p>
             <a:pPr algn="just"/>
             <a:r>
-              <a:rPr lang="ru-RU" sz="2800" b="1" i="0" dirty="0">
-                <a:solidFill>
-                  <a:srgbClr val="F9FAFB"/>
-                </a:solidFill>
-                <a:effectLst/>
-                <a:latin typeface="Nunito Bold" pitchFamily="2" charset="-52"/>
-              </a:rPr>
-              <a:t>Разработанное приложение предназначено для автоматизации учёта заявок, клиентов, устройств и мастеров в сервисном центре по ремонту компьютерной техники.</a:t>
+              <a:rPr lang="ru-RU" sz="4400" b="1" dirty="0">
+                <a:solidFill>
+                  <a:schemeClr val="bg1"/>
+                </a:solidFill>
+              </a:rPr>
+              <a:t>Плюсы алгоритма: </a:t>
+            </a:r>
+            <a:r>
+              <a:rPr lang="ru-RU" sz="4400" dirty="0">
+                <a:solidFill>
+                  <a:schemeClr val="bg1"/>
+                </a:solidFill>
+              </a:rPr>
+              <a:t>Сравнительный анализ показал, что алгоритм «Ближайшего соседа» — один из самых быстрых среди жадных методов. Он делает расчеты мгновенно что хорошо для живой работы курьеров.</a:t>
             </a:r>
           </a:p>
           <a:p>
             <a:pPr algn="just"/>
-            <a:endParaRPr lang="ru-RU" sz="2800" b="1" dirty="0">
+            <a:r>
+              <a:rPr lang="ru-RU" sz="4400" b="1" dirty="0">
+                <a:solidFill>
+                  <a:schemeClr val="bg1"/>
+                </a:solidFill>
+              </a:rPr>
+              <a:t>Практическая польза:</a:t>
+            </a:r>
+            <a:r>
+              <a:rPr lang="ru-RU" sz="4400" dirty="0">
+                <a:solidFill>
+                  <a:schemeClr val="bg1"/>
+                </a:solidFill>
+              </a:rPr>
+              <a:t> Программа полностью готова к интеграции с Яндекс Картами. Она доказывает, что простые жадные алгоритмы могут эффективно решать сложные задачи логистики, экономя время сотрудников и деньги компании.</a:t>
+            </a:r>
+            <a:endParaRPr lang="ru-RU" sz="4400" b="0" i="0" dirty="0">
               <a:solidFill>
-                <a:srgbClr val="F9FAFB"/>
-              </a:solidFill>
-              <a:latin typeface="Nunito Bold" pitchFamily="2" charset="-52"/>
-            </a:endParaRPr>
-          </a:p>
-          <a:p>
-            <a:pPr algn="just"/>
-            <a:r>
-              <a:rPr lang="ru-RU" sz="2800" b="1" i="0" dirty="0">
-                <a:solidFill>
-                  <a:srgbClr val="F9FAFB"/>
-                </a:solidFill>
-                <a:effectLst/>
-                <a:latin typeface="Nunito Bold" pitchFamily="2" charset="-52"/>
-              </a:rPr>
-              <a:t>Программа:</a:t>
-            </a:r>
-            <a:endParaRPr lang="ru-RU" sz="2800" b="0" i="0" dirty="0">
-              <a:solidFill>
-                <a:srgbClr val="F9FAFB"/>
+                <a:schemeClr val="bg1"/>
               </a:solidFill>
               <a:effectLst/>
               <a:latin typeface="Nunito Bold" pitchFamily="2" charset="-52"/>
             </a:endParaRPr>
           </a:p>
+        </p:txBody>
+      </p:sp>
+      <p:sp>
+        <p:nvSpPr>
+          <p:cNvPr id="9" name="Облачко с текстом: овальное 8">
+            <a:extLst>
+              <a:ext uri="{FF2B5EF4-FFF2-40B4-BE49-F238E27FC236}">
+                <a16:creationId xmlns:a16="http://schemas.microsoft.com/office/drawing/2014/main" id="{E2E91762-E914-EB29-CE71-ABEAD58B361C}"/>
+              </a:ext>
+            </a:extLst>
+          </p:cNvPr>
+          <p:cNvSpPr/>
+          <p:nvPr/>
+        </p:nvSpPr>
+        <p:spPr>
+          <a:xfrm>
+            <a:off x="10566400" y="528438"/>
+            <a:ext cx="1079500" cy="741562"/>
+          </a:xfrm>
+          <a:prstGeom prst="wedgeEllipseCallout">
+            <a:avLst/>
+          </a:prstGeom>
+        </p:spPr>
+        <p:style>
+          <a:lnRef idx="2">
+            <a:schemeClr val="dk1"/>
+          </a:lnRef>
+          <a:fillRef idx="1">
+            <a:schemeClr val="lt1"/>
+          </a:fillRef>
+          <a:effectRef idx="0">
+            <a:schemeClr val="dk1"/>
+          </a:effectRef>
+          <a:fontRef idx="minor">
+            <a:schemeClr val="dk1"/>
+          </a:fontRef>
+        </p:style>
+        <p:txBody>
+          <a:bodyPr rtlCol="0" anchor="ctr"/>
+          <a:lstStyle/>
           <a:p>
-            <a:pPr marL="342900" indent="-342900" algn="just">
-              <a:buFont typeface="Wingdings" panose="05000000000000000000" pitchFamily="2" charset="2"/>
-              <a:buChar char="§"/>
-            </a:pPr>
-            <a:r>
-              <a:rPr lang="ru-RU" sz="2800" b="0" i="0" dirty="0">
-                <a:solidFill>
-                  <a:srgbClr val="F9FAFB"/>
-                </a:solidFill>
-                <a:effectLst/>
-                <a:latin typeface="Nunito Bold" pitchFamily="2" charset="-52"/>
-              </a:rPr>
-              <a:t>Использует клиент-серверную архитектуру (</a:t>
-            </a:r>
-            <a:r>
-              <a:rPr lang="ru-RU" sz="2800" b="0" i="0" dirty="0" err="1">
-                <a:solidFill>
-                  <a:srgbClr val="F9FAFB"/>
-                </a:solidFill>
-                <a:effectLst/>
-                <a:latin typeface="Nunito Bold" pitchFamily="2" charset="-52"/>
-              </a:rPr>
-              <a:t>FastAPI</a:t>
-            </a:r>
-            <a:r>
-              <a:rPr lang="ru-RU" sz="2800" b="0" i="0" dirty="0">
-                <a:solidFill>
-                  <a:srgbClr val="F9FAFB"/>
-                </a:solidFill>
-                <a:effectLst/>
-                <a:latin typeface="Nunito Bold" pitchFamily="2" charset="-52"/>
-              </a:rPr>
-              <a:t> + </a:t>
-            </a:r>
-            <a:r>
-              <a:rPr lang="ru-RU" sz="2800" b="0" i="0" dirty="0" err="1">
-                <a:solidFill>
-                  <a:srgbClr val="F9FAFB"/>
-                </a:solidFill>
-                <a:effectLst/>
-                <a:latin typeface="Nunito Bold" pitchFamily="2" charset="-52"/>
-              </a:rPr>
-              <a:t>SQLite</a:t>
-            </a:r>
-            <a:r>
-              <a:rPr lang="ru-RU" sz="2800" b="0" i="0" dirty="0">
-                <a:solidFill>
-                  <a:srgbClr val="F9FAFB"/>
-                </a:solidFill>
-                <a:effectLst/>
-                <a:latin typeface="Nunito Bold" pitchFamily="2" charset="-52"/>
-              </a:rPr>
-              <a:t> + </a:t>
-            </a:r>
-            <a:r>
-              <a:rPr lang="ru-RU" sz="2800" b="0" i="0" dirty="0" err="1">
-                <a:solidFill>
-                  <a:srgbClr val="F9FAFB"/>
-                </a:solidFill>
-                <a:effectLst/>
-                <a:latin typeface="Nunito Bold" pitchFamily="2" charset="-52"/>
-              </a:rPr>
-              <a:t>Bootstrap</a:t>
-            </a:r>
-            <a:r>
-              <a:rPr lang="ru-RU" sz="2800" b="0" i="0" dirty="0">
-                <a:solidFill>
-                  <a:srgbClr val="F9FAFB"/>
-                </a:solidFill>
-                <a:effectLst/>
-                <a:latin typeface="Nunito Bold" pitchFamily="2" charset="-52"/>
-              </a:rPr>
-              <a:t>);</a:t>
-            </a:r>
-          </a:p>
-          <a:p>
-            <a:pPr marL="342900" indent="-342900" algn="just">
-              <a:buFont typeface="Wingdings" panose="05000000000000000000" pitchFamily="2" charset="2"/>
-              <a:buChar char="§"/>
-            </a:pPr>
-            <a:r>
-              <a:rPr lang="ru-RU" sz="2800" b="0" i="0" dirty="0">
-                <a:solidFill>
-                  <a:srgbClr val="F9FAFB"/>
-                </a:solidFill>
-                <a:effectLst/>
-                <a:latin typeface="Nunito Bold" pitchFamily="2" charset="-52"/>
-              </a:rPr>
-              <a:t>Обеспечивает полный цикл управления заявками (создание, назначение мастера, смена статусов);</a:t>
-            </a:r>
-          </a:p>
-          <a:p>
-            <a:pPr marL="342900" indent="-342900" algn="just">
-              <a:buFont typeface="Wingdings" panose="05000000000000000000" pitchFamily="2" charset="2"/>
-              <a:buChar char="§"/>
-            </a:pPr>
-            <a:r>
-              <a:rPr lang="ru-RU" sz="2800" b="0" i="0" dirty="0">
-                <a:solidFill>
-                  <a:srgbClr val="F9FAFB"/>
-                </a:solidFill>
-                <a:effectLst/>
-                <a:latin typeface="Nunito Bold" pitchFamily="2" charset="-52"/>
-              </a:rPr>
-              <a:t>Включает аналитику, финансовые отчёты, поиск, фильтрацию и разграничение прав доступа (администратор, менеджер, мастер).</a:t>
-            </a:r>
+            <a:pPr algn="ctr"/>
+            <a:endParaRPr lang="ru-RU">
+              <a:ln>
+                <a:solidFill>
+                  <a:schemeClr val="tx1"/>
+                </a:solidFill>
+              </a:ln>
+              <a:solidFill>
+                <a:schemeClr val="bg1"/>
+              </a:solidFill>
+            </a:endParaRPr>
           </a:p>
         </p:txBody>
       </p:sp>
-      <p:pic>
-        <p:nvPicPr>
-          <p:cNvPr id="7" name="Рисунок 6">
-            <a:extLst>
-              <a:ext uri="{FF2B5EF4-FFF2-40B4-BE49-F238E27FC236}">
-                <a16:creationId xmlns:a16="http://schemas.microsoft.com/office/drawing/2014/main" id="{10FF7EF3-C749-DF27-D9A9-97881DBDAA3A}"/>
-              </a:ext>
-            </a:extLst>
-          </p:cNvPr>
-          <p:cNvPicPr>
-            <a:picLocks noChangeAspect="1"/>
-          </p:cNvPicPr>
-          <p:nvPr/>
-        </p:nvPicPr>
-        <p:blipFill>
-          <a:blip r:embed="rId3"/>
-          <a:stretch>
-            <a:fillRect/>
-          </a:stretch>
-        </p:blipFill>
-        <p:spPr>
-          <a:xfrm>
-            <a:off x="13623261" y="7613779"/>
-            <a:ext cx="1495135" cy="1495135"/>
-          </a:xfrm>
-          <a:prstGeom prst="rect">
-            <a:avLst/>
-          </a:prstGeom>
-        </p:spPr>
-      </p:pic>
     </p:spTree>
     <p:extLst>
       <p:ext uri="{BB962C8B-B14F-4D97-AF65-F5344CB8AC3E}">

</xml_diff>